<commit_message>
Add founder photos to company profile
Co-Authored-By: Claude Opus 5.5 <noreply@anthropic.com>
Claude-Session: https://claude.ai/code/session_015T4Ky8TkjrkT1kBowiQKVz
</commit_message>
<xml_diff>
--- a/fleetana-launch/brand/profile/Fleetana-Company-Profile-EN.pptx
+++ b/fleetana-launch/brand/profile/Fleetana-Company-Profile-EN.pptx
@@ -126,20 +126,20 @@
   <p:extLst>
     <p:ext uri="{521415D9-36F7-43E2-AB2F-B90AF26B5E84}">
       <p14:sectionLst xmlns:p14="http://schemas.microsoft.com/office/powerpoint/2010/main">
-        <p14:section name="About us" id="{b93d63f3-2f07-d449-e502-36d72f943ce7}">
+        <p14:section name="About us" id="{18645ece-78dd-078f-55c5-c140d0bdb7fe}">
           <p14:sldIdLst>
             <p14:sldId id="256"/>
             <p14:sldId id="257"/>
             <p14:sldId id="258"/>
           </p14:sldIdLst>
         </p14:section>
-        <p14:section name="The problem" id="{2e45f009-1246-88c7-fcf5-7eb09c2f8928}">
+        <p14:section name="The problem" id="{6fb07dc5-508a-24f4-31ae-1dc72e73b832}">
           <p14:sldIdLst>
             <p14:sldId id="259"/>
             <p14:sldId id="260"/>
           </p14:sldIdLst>
         </p14:section>
-        <p14:section name="The solution" id="{5791ada5-6e75-fee7-a7e7-0ad30aef6464}">
+        <p14:section name="The solution" id="{cb518b92-37c0-193d-59b1-02c985491044}">
           <p14:sldIdLst>
             <p14:sldId id="261"/>
             <p14:sldId id="262"/>
@@ -150,20 +150,20 @@
             <p14:sldId id="267"/>
           </p14:sldIdLst>
         </p14:section>
-        <p14:section name="Our trackers" id="{f2018fe6-8292-ec02-915e-e9e954be6aa5}">
+        <p14:section name="Our trackers" id="{2c81eda2-3e31-c3bb-f006-7c2b4cfb829f}">
           <p14:sldIdLst>
             <p14:sldId id="268"/>
             <p14:sldId id="269"/>
             <p14:sldId id="270"/>
           </p14:sldIdLst>
         </p14:section>
-        <p14:section name="The savings" id="{4a17ec5c-9288-4746-2019-7636ee7821e0}">
+        <p14:section name="The savings" id="{61f10fc0-ff95-37ce-380c-32b157035f87}">
           <p14:sldIdLst>
             <p14:sldId id="271"/>
             <p14:sldId id="272"/>
           </p14:sldIdLst>
         </p14:section>
-        <p14:section name="Working with us" id="{09a8e658-60ec-0b94-69b0-b690696c74f8}">
+        <p14:section name="Working with us" id="{f0f293a5-975c-ebf7-2f0d-52586ecca2c7}">
           <p14:sldIdLst>
             <p14:sldId id="273"/>
             <p14:sldId id="274"/>
@@ -11574,14 +11574,14 @@
       </p:sp>
       <p:sp>
         <p:nvSpPr>
-          <p:cNvPr id="4" name="photo-abdallah"/>
-          <p:cNvSpPr txBox="1"/>
-          <p:nvPr/>
-        </p:nvSpPr>
-        <p:spPr>
-          <a:xfrm>
-            <a:off x="982980" y="2395728"/>
-            <a:ext cx="1737360" cy="1737360"/>
+          <p:cNvPr id="4" name="ring-abdallah"/>
+          <p:cNvSpPr/>
+          <p:nvPr/>
+        </p:nvSpPr>
+        <p:spPr>
+          <a:xfrm>
+            <a:off x="918972" y="2331720"/>
+            <a:ext cx="1865376" cy="1865376"/>
           </a:xfrm>
           <a:prstGeom prst="ellipse">
             <a:avLst/>
@@ -11589,40 +11589,87 @@
           <a:solidFill>
             <a:srgbClr val="E8F2FF"/>
           </a:solidFill>
+          <a:ln w="19050">
+            <a:solidFill>
+              <a:srgbClr val="2A89FA"/>
+            </a:solidFill>
+            <a:prstDash val="solid"/>
+          </a:ln>
+        </p:spPr>
+      </p:sp>
+      <p:pic>
+        <p:nvPicPr>
+          <p:cNvPr id="5" name="photo-abdallah" descr="Abdallah Daban">    </p:cNvPr>
+          <p:cNvPicPr>
+            <a:picLocks noChangeAspect="1"/>
+          </p:cNvPicPr>
+          <p:nvPr/>
+        </p:nvPicPr>
+        <p:blipFill>
+          <a:blip r:embed="rId1"/>
+          <a:stretch>
+            <a:fillRect/>
+          </a:stretch>
+        </p:blipFill>
+        <p:spPr>
+          <a:xfrm>
+            <a:off x="982980" y="2395728"/>
+            <a:ext cx="1737360" cy="1737360"/>
+          </a:xfrm>
+          <a:prstGeom prst="ellipse">
+            <a:avLst/>
+          </a:prstGeom>
+        </p:spPr>
+      </p:pic>
+      <p:sp>
+        <p:nvSpPr>
+          <p:cNvPr id="6" name="Text 3"/>
+          <p:cNvSpPr txBox="1"/>
+          <p:nvPr/>
+        </p:nvSpPr>
+        <p:spPr>
+          <a:xfrm>
+            <a:off x="731520" y="4343400"/>
+            <a:ext cx="2240280" cy="685800"/>
+          </a:xfrm>
+          <a:prstGeom prst="rect">
+            <a:avLst/>
+          </a:prstGeom>
+          <a:noFill/>
           <a:ln/>
         </p:spPr>
         <p:txBody>
-          <a:bodyPr wrap="square" lIns="0" tIns="0" rIns="0" bIns="0" rtlCol="0" anchor="ctr"/>
+          <a:bodyPr wrap="square" lIns="0" tIns="0" rIns="0" bIns="0" rtlCol="0" anchor="t"/>
           <a:lstStyle/>
           <a:p>
             <a:pPr algn="ctr" indent="0" marL="0">
               <a:buNone/>
             </a:pPr>
             <a:r>
-              <a:rPr lang="en-US" sz="4400" b="1" dirty="0">
-                <a:solidFill>
-                  <a:srgbClr val="0051D5"/>
+              <a:rPr lang="en-US" sz="1800" b="1" dirty="0">
+                <a:solidFill>
+                  <a:srgbClr val="000000"/>
                 </a:solidFill>
                 <a:latin typeface="Hanken Grotesk" pitchFamily="34" charset="0"/>
                 <a:ea typeface="Hanken Grotesk" pitchFamily="34" charset="-122"/>
                 <a:cs typeface="Hanken Grotesk" pitchFamily="34" charset="-120"/>
               </a:rPr>
-              <a:t>AD</a:t>
-            </a:r>
-            <a:endParaRPr lang="en-US" sz="4400" dirty="0"/>
-          </a:p>
-        </p:txBody>
-      </p:sp>
-      <p:sp>
-        <p:nvSpPr>
-          <p:cNvPr id="5" name="Text 3"/>
+              <a:t>Abdallah Daban</a:t>
+            </a:r>
+            <a:endParaRPr lang="en-US" sz="1800" dirty="0"/>
+          </a:p>
+        </p:txBody>
+      </p:sp>
+      <p:sp>
+        <p:nvSpPr>
+          <p:cNvPr id="7" name="Text 4"/>
           <p:cNvSpPr txBox="1"/>
           <p:nvPr/>
         </p:nvSpPr>
         <p:spPr>
           <a:xfrm>
-            <a:off x="731520" y="4343400"/>
-            <a:ext cx="2240280" cy="685800"/>
+            <a:off x="731520" y="5029200"/>
+            <a:ext cx="2240280" cy="640080"/>
           </a:xfrm>
           <a:prstGeom prst="rect">
             <a:avLst/>
@@ -11638,45 +11685,6 @@
               <a:buNone/>
             </a:pPr>
             <a:r>
-              <a:rPr lang="en-US" sz="1800" b="1" dirty="0">
-                <a:solidFill>
-                  <a:srgbClr val="000000"/>
-                </a:solidFill>
-                <a:latin typeface="Hanken Grotesk" pitchFamily="34" charset="0"/>
-                <a:ea typeface="Hanken Grotesk" pitchFamily="34" charset="-122"/>
-                <a:cs typeface="Hanken Grotesk" pitchFamily="34" charset="-120"/>
-              </a:rPr>
-              <a:t>Abdallah Daban</a:t>
-            </a:r>
-            <a:endParaRPr lang="en-US" sz="1800" dirty="0"/>
-          </a:p>
-        </p:txBody>
-      </p:sp>
-      <p:sp>
-        <p:nvSpPr>
-          <p:cNvPr id="6" name="Text 4"/>
-          <p:cNvSpPr txBox="1"/>
-          <p:nvPr/>
-        </p:nvSpPr>
-        <p:spPr>
-          <a:xfrm>
-            <a:off x="731520" y="5029200"/>
-            <a:ext cx="2240280" cy="640080"/>
-          </a:xfrm>
-          <a:prstGeom prst="rect">
-            <a:avLst/>
-          </a:prstGeom>
-          <a:noFill/>
-          <a:ln/>
-        </p:spPr>
-        <p:txBody>
-          <a:bodyPr wrap="square" lIns="0" tIns="0" rIns="0" bIns="0" rtlCol="0" anchor="t"/>
-          <a:lstStyle/>
-          <a:p>
-            <a:pPr algn="ctr" indent="0" marL="0">
-              <a:buNone/>
-            </a:pPr>
-            <a:r>
               <a:rPr lang="en-US" sz="1350" dirty="0">
                 <a:solidFill>
                   <a:srgbClr val="0051D5"/>
@@ -11690,7 +11698,7 @@
       </p:sp>
       <p:sp>
         <p:nvSpPr>
-          <p:cNvPr id="7" name="team-abdulrahman"/>
+          <p:cNvPr id="8" name="team-abdulrahman"/>
           <p:cNvSpPr/>
           <p:nvPr/>
         </p:nvSpPr>
@@ -11724,14 +11732,14 @@
       </p:sp>
       <p:sp>
         <p:nvSpPr>
-          <p:cNvPr id="8" name="photo-abdulrahman"/>
-          <p:cNvSpPr txBox="1"/>
-          <p:nvPr/>
-        </p:nvSpPr>
-        <p:spPr>
-          <a:xfrm>
-            <a:off x="3790188" y="2395728"/>
-            <a:ext cx="1737360" cy="1737360"/>
+          <p:cNvPr id="9" name="ring-abdulrahman"/>
+          <p:cNvSpPr/>
+          <p:nvPr/>
+        </p:nvSpPr>
+        <p:spPr>
+          <a:xfrm>
+            <a:off x="3726180" y="2331720"/>
+            <a:ext cx="1865376" cy="1865376"/>
           </a:xfrm>
           <a:prstGeom prst="ellipse">
             <a:avLst/>
@@ -11739,40 +11747,87 @@
           <a:solidFill>
             <a:srgbClr val="E8F2FF"/>
           </a:solidFill>
+          <a:ln w="19050">
+            <a:solidFill>
+              <a:srgbClr val="2A89FA"/>
+            </a:solidFill>
+            <a:prstDash val="solid"/>
+          </a:ln>
+        </p:spPr>
+      </p:sp>
+      <p:pic>
+        <p:nvPicPr>
+          <p:cNvPr id="10" name="photo-abdulrahman" descr="Abdulrahman Alaskar">    </p:cNvPr>
+          <p:cNvPicPr>
+            <a:picLocks noChangeAspect="1"/>
+          </p:cNvPicPr>
+          <p:nvPr/>
+        </p:nvPicPr>
+        <p:blipFill>
+          <a:blip r:embed="rId2"/>
+          <a:stretch>
+            <a:fillRect/>
+          </a:stretch>
+        </p:blipFill>
+        <p:spPr>
+          <a:xfrm>
+            <a:off x="3790188" y="2395728"/>
+            <a:ext cx="1737360" cy="1737360"/>
+          </a:xfrm>
+          <a:prstGeom prst="ellipse">
+            <a:avLst/>
+          </a:prstGeom>
+        </p:spPr>
+      </p:pic>
+      <p:sp>
+        <p:nvSpPr>
+          <p:cNvPr id="11" name="Text 7"/>
+          <p:cNvSpPr txBox="1"/>
+          <p:nvPr/>
+        </p:nvSpPr>
+        <p:spPr>
+          <a:xfrm>
+            <a:off x="3538728" y="4343400"/>
+            <a:ext cx="2240280" cy="685800"/>
+          </a:xfrm>
+          <a:prstGeom prst="rect">
+            <a:avLst/>
+          </a:prstGeom>
+          <a:noFill/>
           <a:ln/>
         </p:spPr>
         <p:txBody>
-          <a:bodyPr wrap="square" lIns="0" tIns="0" rIns="0" bIns="0" rtlCol="0" anchor="ctr"/>
+          <a:bodyPr wrap="square" lIns="0" tIns="0" rIns="0" bIns="0" rtlCol="0" anchor="t"/>
           <a:lstStyle/>
           <a:p>
             <a:pPr algn="ctr" indent="0" marL="0">
               <a:buNone/>
             </a:pPr>
             <a:r>
-              <a:rPr lang="en-US" sz="4400" b="1" dirty="0">
-                <a:solidFill>
-                  <a:srgbClr val="0051D5"/>
+              <a:rPr lang="en-US" sz="1800" b="1" dirty="0">
+                <a:solidFill>
+                  <a:srgbClr val="000000"/>
                 </a:solidFill>
                 <a:latin typeface="Hanken Grotesk" pitchFamily="34" charset="0"/>
                 <a:ea typeface="Hanken Grotesk" pitchFamily="34" charset="-122"/>
                 <a:cs typeface="Hanken Grotesk" pitchFamily="34" charset="-120"/>
               </a:rPr>
-              <a:t>AA</a:t>
-            </a:r>
-            <a:endParaRPr lang="en-US" sz="4400" dirty="0"/>
-          </a:p>
-        </p:txBody>
-      </p:sp>
-      <p:sp>
-        <p:nvSpPr>
-          <p:cNvPr id="9" name="Text 7"/>
+              <a:t>Abdulrahman Alaskar</a:t>
+            </a:r>
+            <a:endParaRPr lang="en-US" sz="1800" dirty="0"/>
+          </a:p>
+        </p:txBody>
+      </p:sp>
+      <p:sp>
+        <p:nvSpPr>
+          <p:cNvPr id="12" name="Text 8"/>
           <p:cNvSpPr txBox="1"/>
           <p:nvPr/>
         </p:nvSpPr>
         <p:spPr>
           <a:xfrm>
-            <a:off x="3538728" y="4343400"/>
-            <a:ext cx="2240280" cy="685800"/>
+            <a:off x="3538728" y="5029200"/>
+            <a:ext cx="2240280" cy="640080"/>
           </a:xfrm>
           <a:prstGeom prst="rect">
             <a:avLst/>
@@ -11788,45 +11843,6 @@
               <a:buNone/>
             </a:pPr>
             <a:r>
-              <a:rPr lang="en-US" sz="1800" b="1" dirty="0">
-                <a:solidFill>
-                  <a:srgbClr val="000000"/>
-                </a:solidFill>
-                <a:latin typeface="Hanken Grotesk" pitchFamily="34" charset="0"/>
-                <a:ea typeface="Hanken Grotesk" pitchFamily="34" charset="-122"/>
-                <a:cs typeface="Hanken Grotesk" pitchFamily="34" charset="-120"/>
-              </a:rPr>
-              <a:t>Abdulrahman Alaskar</a:t>
-            </a:r>
-            <a:endParaRPr lang="en-US" sz="1800" dirty="0"/>
-          </a:p>
-        </p:txBody>
-      </p:sp>
-      <p:sp>
-        <p:nvSpPr>
-          <p:cNvPr id="10" name="Text 8"/>
-          <p:cNvSpPr txBox="1"/>
-          <p:nvPr/>
-        </p:nvSpPr>
-        <p:spPr>
-          <a:xfrm>
-            <a:off x="3538728" y="5029200"/>
-            <a:ext cx="2240280" cy="640080"/>
-          </a:xfrm>
-          <a:prstGeom prst="rect">
-            <a:avLst/>
-          </a:prstGeom>
-          <a:noFill/>
-          <a:ln/>
-        </p:spPr>
-        <p:txBody>
-          <a:bodyPr wrap="square" lIns="0" tIns="0" rIns="0" bIns="0" rtlCol="0" anchor="t"/>
-          <a:lstStyle/>
-          <a:p>
-            <a:pPr algn="ctr" indent="0" marL="0">
-              <a:buNone/>
-            </a:pPr>
-            <a:r>
               <a:rPr lang="en-US" sz="1350" dirty="0">
                 <a:solidFill>
                   <a:srgbClr val="0051D5"/>
@@ -11840,7 +11856,7 @@
       </p:sp>
       <p:sp>
         <p:nvSpPr>
-          <p:cNvPr id="11" name="team-faisal"/>
+          <p:cNvPr id="13" name="team-faisal"/>
           <p:cNvSpPr/>
           <p:nvPr/>
         </p:nvSpPr>
@@ -11874,14 +11890,14 @@
       </p:sp>
       <p:sp>
         <p:nvSpPr>
-          <p:cNvPr id="12" name="photo-faisal"/>
-          <p:cNvSpPr txBox="1"/>
-          <p:nvPr/>
-        </p:nvSpPr>
-        <p:spPr>
-          <a:xfrm>
-            <a:off x="6597396" y="2395728"/>
-            <a:ext cx="1737360" cy="1737360"/>
+          <p:cNvPr id="14" name="ring-faisal"/>
+          <p:cNvSpPr/>
+          <p:nvPr/>
+        </p:nvSpPr>
+        <p:spPr>
+          <a:xfrm>
+            <a:off x="6533388" y="2331720"/>
+            <a:ext cx="1865376" cy="1865376"/>
           </a:xfrm>
           <a:prstGeom prst="ellipse">
             <a:avLst/>
@@ -11889,40 +11905,87 @@
           <a:solidFill>
             <a:srgbClr val="E8F2FF"/>
           </a:solidFill>
+          <a:ln w="19050">
+            <a:solidFill>
+              <a:srgbClr val="2A89FA"/>
+            </a:solidFill>
+            <a:prstDash val="solid"/>
+          </a:ln>
+        </p:spPr>
+      </p:sp>
+      <p:pic>
+        <p:nvPicPr>
+          <p:cNvPr id="15" name="photo-faisal" descr="Faisal Qassem">    </p:cNvPr>
+          <p:cNvPicPr>
+            <a:picLocks noChangeAspect="1"/>
+          </p:cNvPicPr>
+          <p:nvPr/>
+        </p:nvPicPr>
+        <p:blipFill>
+          <a:blip r:embed="rId3"/>
+          <a:stretch>
+            <a:fillRect/>
+          </a:stretch>
+        </p:blipFill>
+        <p:spPr>
+          <a:xfrm>
+            <a:off x="6597396" y="2395728"/>
+            <a:ext cx="1737360" cy="1737360"/>
+          </a:xfrm>
+          <a:prstGeom prst="ellipse">
+            <a:avLst/>
+          </a:prstGeom>
+        </p:spPr>
+      </p:pic>
+      <p:sp>
+        <p:nvSpPr>
+          <p:cNvPr id="16" name="Text 11"/>
+          <p:cNvSpPr txBox="1"/>
+          <p:nvPr/>
+        </p:nvSpPr>
+        <p:spPr>
+          <a:xfrm>
+            <a:off x="6345936" y="4343400"/>
+            <a:ext cx="2240280" cy="685800"/>
+          </a:xfrm>
+          <a:prstGeom prst="rect">
+            <a:avLst/>
+          </a:prstGeom>
+          <a:noFill/>
           <a:ln/>
         </p:spPr>
         <p:txBody>
-          <a:bodyPr wrap="square" lIns="0" tIns="0" rIns="0" bIns="0" rtlCol="0" anchor="ctr"/>
+          <a:bodyPr wrap="square" lIns="0" tIns="0" rIns="0" bIns="0" rtlCol="0" anchor="t"/>
           <a:lstStyle/>
           <a:p>
             <a:pPr algn="ctr" indent="0" marL="0">
               <a:buNone/>
             </a:pPr>
             <a:r>
-              <a:rPr lang="en-US" sz="4400" b="1" dirty="0">
-                <a:solidFill>
-                  <a:srgbClr val="0051D5"/>
+              <a:rPr lang="en-US" sz="1800" b="1" dirty="0">
+                <a:solidFill>
+                  <a:srgbClr val="000000"/>
                 </a:solidFill>
                 <a:latin typeface="Hanken Grotesk" pitchFamily="34" charset="0"/>
                 <a:ea typeface="Hanken Grotesk" pitchFamily="34" charset="-122"/>
                 <a:cs typeface="Hanken Grotesk" pitchFamily="34" charset="-120"/>
               </a:rPr>
-              <a:t>FQ</a:t>
-            </a:r>
-            <a:endParaRPr lang="en-US" sz="4400" dirty="0"/>
-          </a:p>
-        </p:txBody>
-      </p:sp>
-      <p:sp>
-        <p:nvSpPr>
-          <p:cNvPr id="13" name="Text 11"/>
+              <a:t>Faisal Qassem</a:t>
+            </a:r>
+            <a:endParaRPr lang="en-US" sz="1800" dirty="0"/>
+          </a:p>
+        </p:txBody>
+      </p:sp>
+      <p:sp>
+        <p:nvSpPr>
+          <p:cNvPr id="17" name="Text 12"/>
           <p:cNvSpPr txBox="1"/>
           <p:nvPr/>
         </p:nvSpPr>
         <p:spPr>
           <a:xfrm>
-            <a:off x="6345936" y="4343400"/>
-            <a:ext cx="2240280" cy="685800"/>
+            <a:off x="6345936" y="5029200"/>
+            <a:ext cx="2240280" cy="640080"/>
           </a:xfrm>
           <a:prstGeom prst="rect">
             <a:avLst/>
@@ -11938,45 +12001,6 @@
               <a:buNone/>
             </a:pPr>
             <a:r>
-              <a:rPr lang="en-US" sz="1800" b="1" dirty="0">
-                <a:solidFill>
-                  <a:srgbClr val="000000"/>
-                </a:solidFill>
-                <a:latin typeface="Hanken Grotesk" pitchFamily="34" charset="0"/>
-                <a:ea typeface="Hanken Grotesk" pitchFamily="34" charset="-122"/>
-                <a:cs typeface="Hanken Grotesk" pitchFamily="34" charset="-120"/>
-              </a:rPr>
-              <a:t>Faisal Qassem</a:t>
-            </a:r>
-            <a:endParaRPr lang="en-US" sz="1800" dirty="0"/>
-          </a:p>
-        </p:txBody>
-      </p:sp>
-      <p:sp>
-        <p:nvSpPr>
-          <p:cNvPr id="14" name="Text 12"/>
-          <p:cNvSpPr txBox="1"/>
-          <p:nvPr/>
-        </p:nvSpPr>
-        <p:spPr>
-          <a:xfrm>
-            <a:off x="6345936" y="5029200"/>
-            <a:ext cx="2240280" cy="640080"/>
-          </a:xfrm>
-          <a:prstGeom prst="rect">
-            <a:avLst/>
-          </a:prstGeom>
-          <a:noFill/>
-          <a:ln/>
-        </p:spPr>
-        <p:txBody>
-          <a:bodyPr wrap="square" lIns="0" tIns="0" rIns="0" bIns="0" rtlCol="0" anchor="t"/>
-          <a:lstStyle/>
-          <a:p>
-            <a:pPr algn="ctr" indent="0" marL="0">
-              <a:buNone/>
-            </a:pPr>
-            <a:r>
               <a:rPr lang="en-US" sz="1350" dirty="0">
                 <a:solidFill>
                   <a:srgbClr val="0051D5"/>
@@ -11990,7 +12014,7 @@
       </p:sp>
       <p:sp>
         <p:nvSpPr>
-          <p:cNvPr id="15" name="team-ali"/>
+          <p:cNvPr id="18" name="team-ali"/>
           <p:cNvSpPr/>
           <p:nvPr/>
         </p:nvSpPr>
@@ -12024,14 +12048,14 @@
       </p:sp>
       <p:sp>
         <p:nvSpPr>
-          <p:cNvPr id="16" name="photo-ali"/>
-          <p:cNvSpPr txBox="1"/>
-          <p:nvPr/>
-        </p:nvSpPr>
-        <p:spPr>
-          <a:xfrm>
-            <a:off x="9404604" y="2395728"/>
-            <a:ext cx="1737360" cy="1737360"/>
+          <p:cNvPr id="19" name="ring-ali"/>
+          <p:cNvSpPr/>
+          <p:nvPr/>
+        </p:nvSpPr>
+        <p:spPr>
+          <a:xfrm>
+            <a:off x="9340596" y="2331720"/>
+            <a:ext cx="1865376" cy="1865376"/>
           </a:xfrm>
           <a:prstGeom prst="ellipse">
             <a:avLst/>
@@ -12039,63 +12063,71 @@
           <a:solidFill>
             <a:srgbClr val="E8F2FF"/>
           </a:solidFill>
+          <a:ln w="19050">
+            <a:solidFill>
+              <a:srgbClr val="2A89FA"/>
+            </a:solidFill>
+            <a:prstDash val="solid"/>
+          </a:ln>
+        </p:spPr>
+      </p:sp>
+      <p:pic>
+        <p:nvPicPr>
+          <p:cNvPr id="20" name="photo-ali" descr="Ali Choudhary">    </p:cNvPr>
+          <p:cNvPicPr>
+            <a:picLocks noChangeAspect="1"/>
+          </p:cNvPicPr>
+          <p:nvPr/>
+        </p:nvPicPr>
+        <p:blipFill>
+          <a:blip r:embed="rId4"/>
+          <a:stretch>
+            <a:fillRect/>
+          </a:stretch>
+        </p:blipFill>
+        <p:spPr>
+          <a:xfrm>
+            <a:off x="9404604" y="2395728"/>
+            <a:ext cx="1737360" cy="1737360"/>
+          </a:xfrm>
+          <a:prstGeom prst="ellipse">
+            <a:avLst/>
+          </a:prstGeom>
+        </p:spPr>
+      </p:pic>
+      <p:sp>
+        <p:nvSpPr>
+          <p:cNvPr id="21" name="Text 15"/>
+          <p:cNvSpPr txBox="1"/>
+          <p:nvPr/>
+        </p:nvSpPr>
+        <p:spPr>
+          <a:xfrm>
+            <a:off x="9153144" y="4343400"/>
+            <a:ext cx="2240280" cy="685800"/>
+          </a:xfrm>
+          <a:prstGeom prst="rect">
+            <a:avLst/>
+          </a:prstGeom>
+          <a:noFill/>
           <a:ln/>
         </p:spPr>
         <p:txBody>
-          <a:bodyPr wrap="square" lIns="0" tIns="0" rIns="0" bIns="0" rtlCol="0" anchor="ctr"/>
+          <a:bodyPr wrap="square" lIns="0" tIns="0" rIns="0" bIns="0" rtlCol="0" anchor="t"/>
           <a:lstStyle/>
           <a:p>
             <a:pPr algn="ctr" indent="0" marL="0">
               <a:buNone/>
             </a:pPr>
             <a:r>
-              <a:rPr lang="en-US" sz="4400" b="1" dirty="0">
-                <a:solidFill>
-                  <a:srgbClr val="0051D5"/>
+              <a:rPr lang="en-US" sz="1800" b="1" dirty="0">
+                <a:solidFill>
+                  <a:srgbClr val="000000"/>
                 </a:solidFill>
                 <a:latin typeface="Hanken Grotesk" pitchFamily="34" charset="0"/>
                 <a:ea typeface="Hanken Grotesk" pitchFamily="34" charset="-122"/>
                 <a:cs typeface="Hanken Grotesk" pitchFamily="34" charset="-120"/>
               </a:rPr>
-              <a:t>AC</a:t>
-            </a:r>
-            <a:endParaRPr lang="en-US" sz="4400" dirty="0"/>
-          </a:p>
-        </p:txBody>
-      </p:sp>
-      <p:sp>
-        <p:nvSpPr>
-          <p:cNvPr id="17" name="Text 15"/>
-          <p:cNvSpPr txBox="1"/>
-          <p:nvPr/>
-        </p:nvSpPr>
-        <p:spPr>
-          <a:xfrm>
-            <a:off x="9153144" y="4343400"/>
-            <a:ext cx="2240280" cy="685800"/>
-          </a:xfrm>
-          <a:prstGeom prst="rect">
-            <a:avLst/>
-          </a:prstGeom>
-          <a:noFill/>
-          <a:ln/>
-        </p:spPr>
-        <p:txBody>
-          <a:bodyPr wrap="square" lIns="0" tIns="0" rIns="0" bIns="0" rtlCol="0" anchor="t"/>
-          <a:lstStyle/>
-          <a:p>
-            <a:pPr algn="ctr" indent="0" marL="0">
-              <a:buNone/>
-            </a:pPr>
-            <a:r>
-              <a:rPr lang="en-US" sz="1800" b="1" dirty="0">
-                <a:solidFill>
-                  <a:srgbClr val="000000"/>
-                </a:solidFill>
-                <a:latin typeface="Hanken Grotesk" pitchFamily="34" charset="0"/>
-                <a:ea typeface="Hanken Grotesk" pitchFamily="34" charset="-122"/>
-                <a:cs typeface="Hanken Grotesk" pitchFamily="34" charset="-120"/>
-              </a:rPr>
               <a:t>Ali Choudhary</a:t>
             </a:r>
             <a:endParaRPr lang="en-US" sz="1800" dirty="0"/>
@@ -12104,7 +12136,7 @@
       </p:sp>
       <p:sp>
         <p:nvSpPr>
-          <p:cNvPr id="18" name="Text 16"/>
+          <p:cNvPr id="22" name="Text 16"/>
           <p:cNvSpPr txBox="1"/>
           <p:nvPr/>
         </p:nvSpPr>

</xml_diff>

<commit_message>
Add Arabic company profile; contact email admin@fleetana.sa
Arabic profile written natively with the app's terms. Titles, placeholders
and bullet lists now carry right-to-left paragraph direction, which also
fixes punctuation and bullet placement in the Arabic template.

Co-Authored-By: Claude Opus 5.5 <noreply@anthropic.com>
Claude-Session: https://claude.ai/code/session_015T4Ky8TkjrkT1kBowiQKVz
</commit_message>
<xml_diff>
--- a/fleetana-launch/brand/profile/Fleetana-Company-Profile-EN.pptx
+++ b/fleetana-launch/brand/profile/Fleetana-Company-Profile-EN.pptx
@@ -126,20 +126,20 @@
   <p:extLst>
     <p:ext uri="{521415D9-36F7-43E2-AB2F-B90AF26B5E84}">
       <p14:sectionLst xmlns:p14="http://schemas.microsoft.com/office/powerpoint/2010/main">
-        <p14:section name="About us" id="{18645ece-78dd-078f-55c5-c140d0bdb7fe}">
+        <p14:section name="About us" id="{29f0f00c-90ce-6065-6bc0-60b7938366a4}">
           <p14:sldIdLst>
             <p14:sldId id="256"/>
             <p14:sldId id="257"/>
             <p14:sldId id="258"/>
           </p14:sldIdLst>
         </p14:section>
-        <p14:section name="The problem" id="{6fb07dc5-508a-24f4-31ae-1dc72e73b832}">
+        <p14:section name="The problem" id="{a030ba40-42eb-0437-6699-dc9dc741e87d}">
           <p14:sldIdLst>
             <p14:sldId id="259"/>
             <p14:sldId id="260"/>
           </p14:sldIdLst>
         </p14:section>
-        <p14:section name="The solution" id="{cb518b92-37c0-193d-59b1-02c985491044}">
+        <p14:section name="The solution" id="{e15e4e0d-5728-98d0-87f2-2088bd30554f}">
           <p14:sldIdLst>
             <p14:sldId id="261"/>
             <p14:sldId id="262"/>
@@ -150,20 +150,20 @@
             <p14:sldId id="267"/>
           </p14:sldIdLst>
         </p14:section>
-        <p14:section name="Our trackers" id="{2c81eda2-3e31-c3bb-f006-7c2b4cfb829f}">
+        <p14:section name="Our trackers" id="{3e233ead-3976-bd24-10b8-4dfd758048fd}">
           <p14:sldIdLst>
             <p14:sldId id="268"/>
             <p14:sldId id="269"/>
             <p14:sldId id="270"/>
           </p14:sldIdLst>
         </p14:section>
-        <p14:section name="The savings" id="{61f10fc0-ff95-37ce-380c-32b157035f87}">
+        <p14:section name="The savings" id="{ac6f830e-ee70-0cbc-cfc6-5840c14a719d}">
           <p14:sldIdLst>
             <p14:sldId id="271"/>
             <p14:sldId id="272"/>
           </p14:sldIdLst>
         </p14:section>
-        <p14:section name="Working with us" id="{f0f293a5-975c-ebf7-2f0d-52586ecca2c7}">
+        <p14:section name="Working with us" id="{1f3dedba-707c-3044-3b05-636b477854dc}">
           <p14:sldIdLst>
             <p14:sldId id="273"/>
             <p14:sldId id="274"/>
@@ -13001,7 +13001,7 @@
                   <a:srgbClr val="0051D5"/>
                 </a:solidFill>
               </a:rPr>
-              <a:t>fleetana.sa  ·  info@fleetana.sa</a:t>
+              <a:t>fleetana.sa  ·  admin@fleetana.sa</a:t>
             </a:r>
             <a:endParaRPr lang="en-US" sz="2000" dirty="0"/>
           </a:p>

</xml_diff>